<commit_message>
Add WHY_THIS_PRODUCT.md; sharpen deck open/close; regenerate exports
- WHY_THIS_PRODUCT.md: plain-English brief — what the product does, how it
  maps to all 5 grading criteria, why it's the right answer (interview prep)
- DECK.md: stronger opening ("I didn't build one agent — I built the layer
  that makes all the agents possible") and closing ("why this is the right
  answer, not just an answer")
- Regenerated deck PDF + PPTX to match

Co-Authored-By: Claude Opus 4.8 <noreply@anthropic.com>
Claude-Session: https://claude.ai/code/session_01YSBd5UwWXaz3oS3KJNG9Fg
</commit_message>
<xml_diff>
--- a/exports/Velocity-Context-Layer-Deck.pptx
+++ b/exports/Velocity-Context-Layer-Deck.pptx
@@ -5564,7 +5564,82 @@
                   <a:srgbClr val="6D28D9"/>
                 </a:solidFill>
               </a:rPr>
-              <a:t>The prototype makes that clickable. This deck is how it scales.</a:t>
+              <a:t>Why this is the right answer, not just an answer:</a:t>
+            </a:r>
+          </a:p>
+          <a:p>
+            <a:pPr>
+              <a:spcAft>
+                <a:spcPts val="400"/>
+              </a:spcAft>
+            </a:pPr>
+            <a:r>
+              <a:rPr sz="1500">
+                <a:solidFill>
+                  <a:srgbClr val="0F172A"/>
+                </a:solidFill>
+              </a:rPr>
+              <a:t>• It fixes the shared bottleneck every agent has — not one feature in isolation.</a:t>
+            </a:r>
+          </a:p>
+          <a:p>
+            <a:pPr>
+              <a:spcAft>
+                <a:spcPts val="400"/>
+              </a:spcAft>
+            </a:pPr>
+            <a:r>
+              <a:rPr sz="1500">
+                <a:solidFill>
+                  <a:srgbClr val="0F172A"/>
+                </a:solidFill>
+              </a:rPr>
+              <a:t>• It's AI-first and proven live — English → segment, minimal context → real message.</a:t>
+            </a:r>
+          </a:p>
+          <a:p>
+            <a:pPr>
+              <a:spcAft>
+                <a:spcPts val="400"/>
+              </a:spcAft>
+            </a:pPr>
+            <a:r>
+              <a:rPr sz="1500">
+                <a:solidFill>
+                  <a:srgbClr val="0F172A"/>
+                </a:solidFill>
+              </a:rPr>
+              <a:t>• It serves products not built yet — new agent = new contract, no re-architecture.</a:t>
+            </a:r>
+          </a:p>
+          <a:p>
+            <a:pPr>
+              <a:spcAft>
+                <a:spcPts val="400"/>
+              </a:spcAft>
+            </a:pPr>
+            <a:r>
+              <a:rPr sz="1500">
+                <a:solidFill>
+                  <a:srgbClr val="0F172A"/>
+                </a:solidFill>
+              </a:rPr>
+              <a:t>• The restraint is deliberate — no DB, no auth, no fake integrations; knowing what not to build is the same judgment the roadmap question tests.</a:t>
+            </a:r>
+          </a:p>
+          <a:p>
+            <a:pPr>
+              <a:spcBef>
+                <a:spcPts val="800"/>
+              </a:spcBef>
+            </a:pPr>
+            <a:r>
+              <a:rPr sz="1600" b="1">
+                <a:solidFill>
+                  <a:srgbClr val="6D28D9"/>
+                </a:solidFill>
+              </a:rPr>
+              <a:t>The prototype makes it clickable. This deck is how it scales.</a:t>
             </a:r>
           </a:p>
         </p:txBody>
@@ -5737,6 +5812,21 @@
           <a:lstStyle/>
           <a:p>
             <a:pPr>
+              <a:spcBef>
+                <a:spcPts val="800"/>
+              </a:spcBef>
+            </a:pPr>
+            <a:r>
+              <a:rPr sz="1600" b="1">
+                <a:solidFill>
+                  <a:srgbClr val="6D28D9"/>
+                </a:solidFill>
+              </a:rPr>
+              <a:t>I didn't build one agent. I built the layer that makes all the agents possible.</a:t>
+            </a:r>
+          </a:p>
+          <a:p>
+            <a:pPr>
               <a:spcAft>
                 <a:spcPts val="400"/>
               </a:spcAft>
@@ -5747,22 +5837,7 @@
                   <a:srgbClr val="0F172A"/>
                 </a:solidFill>
               </a:rPr>
-              <a:t>A CDP answers one question: "Who is my customer?"</a:t>
-            </a:r>
-          </a:p>
-          <a:p>
-            <a:pPr>
-              <a:spcAft>
-                <a:spcPts val="400"/>
-              </a:spcAft>
-            </a:pPr>
-            <a:r>
-              <a:rPr sz="1400">
-                <a:solidFill>
-                  <a:srgbClr val="0F172A"/>
-                </a:solidFill>
-              </a:rPr>
-              <a:t>But an agent about to act doesn't need a 360° profile. It needs the few facts that change its decision, right now.</a:t>
+              <a:t>A CDP answers one question: "Who is my customer?" But an agent about to act doesn't need a 360° profile. It needs the few facts that change its decision, right now.</a:t>
             </a:r>
           </a:p>
           <a:p>
@@ -5816,7 +5891,7 @@
                   <a:srgbClr val="6D28D9"/>
                 </a:solidFill>
               </a:rPr>
-              <a:t>— and stays cheap to extend as we add agents and brands.</a:t>
+              <a:t>— and because it's one platform across many brands, the data compounds into a moat no single brand can build.</a:t>
             </a:r>
           </a:p>
           <a:p>
@@ -5831,7 +5906,7 @@
                   <a:srgbClr val="0F172A"/>
                 </a:solidFill>
               </a:rPr>
-              <a:t>Everything below follows from taking that sentence literally.</a:t>
+              <a:t>Every agent on the roadmap fails the same way: it acts on partial context. Fix the context layer once, and every agent — today's and the ones not built yet — gets better at the same time. Everything below follows from taking that one sentence literally.</a:t>
             </a:r>
           </a:p>
           <a:p>

</xml_diff>

<commit_message>
Add 10-slide short deck and per-slide speaker notes to all PPTX exports
- DECK_SHORT.md: tight 10-slide version for time-boxed presentations
- All PPTX decks (full + short) now carry per-slide speaker notes — a
  spoken script for each slide
- Regenerated full + short PDF and PPTX; updated DEMO_GUIDE file index

Co-Authored-By: Claude Opus 4.8 <noreply@anthropic.com>
Claude-Session: https://claude.ai/code/session_01YSBd5UwWXaz3oS3KJNG9Fg
</commit_message>
<xml_diff>
--- a/exports/Velocity-Context-Layer-Deck.pptx
+++ b/exports/Velocity-Context-Layer-Deck.pptx
@@ -6,22 +6,22 @@
   </p:sldMasterIdLst>
   <p:sldIdLst>
     <p:sldId id="256" r:id="rId7"/>
-    <p:sldId id="257" r:id="rId8"/>
-    <p:sldId id="258" r:id="rId9"/>
-    <p:sldId id="259" r:id="rId10"/>
-    <p:sldId id="260" r:id="rId11"/>
-    <p:sldId id="261" r:id="rId12"/>
-    <p:sldId id="262" r:id="rId13"/>
-    <p:sldId id="263" r:id="rId14"/>
-    <p:sldId id="264" r:id="rId15"/>
-    <p:sldId id="265" r:id="rId16"/>
-    <p:sldId id="266" r:id="rId17"/>
-    <p:sldId id="267" r:id="rId18"/>
-    <p:sldId id="268" r:id="rId19"/>
-    <p:sldId id="269" r:id="rId20"/>
-    <p:sldId id="270" r:id="rId21"/>
-    <p:sldId id="271" r:id="rId22"/>
-    <p:sldId id="272" r:id="rId23"/>
+    <p:sldId id="257" r:id="rId9"/>
+    <p:sldId id="258" r:id="rId10"/>
+    <p:sldId id="259" r:id="rId11"/>
+    <p:sldId id="260" r:id="rId12"/>
+    <p:sldId id="261" r:id="rId13"/>
+    <p:sldId id="262" r:id="rId14"/>
+    <p:sldId id="263" r:id="rId15"/>
+    <p:sldId id="264" r:id="rId16"/>
+    <p:sldId id="265" r:id="rId17"/>
+    <p:sldId id="266" r:id="rId18"/>
+    <p:sldId id="267" r:id="rId19"/>
+    <p:sldId id="268" r:id="rId20"/>
+    <p:sldId id="269" r:id="rId21"/>
+    <p:sldId id="270" r:id="rId22"/>
+    <p:sldId id="271" r:id="rId23"/>
+    <p:sldId id="272" r:id="rId24"/>
   </p:sldIdLst>
   <p:sldSz cx="12191695" cy="6858000" type="screen4x3"/>
   <p:notesSz cx="6858000" cy="9144000"/>
@@ -121,6 +121,1546 @@
     </a:lvl9pPr>
   </p:defaultTextStyle>
 </p:presentation>
+</file>
+
+<file path=ppt/notesMasters/notesMaster1.xml><?xml version="1.0" encoding="utf-8"?>
+<p:notesMaster xmlns:a="http://schemas.openxmlformats.org/drawingml/2006/main" xmlns:p="http://schemas.openxmlformats.org/presentationml/2006/main" xmlns:r="http://schemas.openxmlformats.org/officeDocument/2006/relationships">
+  <p:cSld>
+    <p:bg>
+      <p:bgRef idx="1001">
+        <a:schemeClr val="bg1"/>
+      </p:bgRef>
+    </p:bg>
+    <p:spTree>
+      <p:nvGrpSpPr>
+        <p:cNvPr id="1" name=""/>
+        <p:cNvGrpSpPr/>
+        <p:nvPr/>
+      </p:nvGrpSpPr>
+      <p:grpSpPr>
+        <a:xfrm>
+          <a:off x="0" y="0"/>
+          <a:ext cx="0" cy="0"/>
+          <a:chOff x="0" y="0"/>
+          <a:chExt cx="0" cy="0"/>
+        </a:xfrm>
+      </p:grpSpPr>
+      <p:sp>
+        <p:nvSpPr>
+          <p:cNvPr id="2" name="Header Placeholder 1"/>
+          <p:cNvSpPr>
+            <a:spLocks noGrp="1"/>
+          </p:cNvSpPr>
+          <p:nvPr>
+            <p:ph type="hdr" sz="quarter"/>
+          </p:nvPr>
+        </p:nvSpPr>
+        <p:spPr>
+          <a:xfrm>
+            <a:off x="0" y="0"/>
+            <a:ext cx="2971800" cy="457200"/>
+          </a:xfrm>
+          <a:prstGeom prst="rect">
+            <a:avLst/>
+          </a:prstGeom>
+        </p:spPr>
+        <p:txBody>
+          <a:bodyPr vert="horz" lIns="91440" tIns="45720" rIns="91440" bIns="45720" rtlCol="0"/>
+          <a:lstStyle>
+            <a:lvl1pPr algn="l">
+              <a:defRPr sz="1200"/>
+            </a:lvl1pPr>
+          </a:lstStyle>
+          <a:p>
+            <a:endParaRPr lang="en-US"/>
+          </a:p>
+        </p:txBody>
+      </p:sp>
+      <p:sp>
+        <p:nvSpPr>
+          <p:cNvPr id="3" name="Date Placeholder 2"/>
+          <p:cNvSpPr>
+            <a:spLocks noGrp="1"/>
+          </p:cNvSpPr>
+          <p:nvPr>
+            <p:ph type="dt" idx="1"/>
+          </p:nvPr>
+        </p:nvSpPr>
+        <p:spPr>
+          <a:xfrm>
+            <a:off x="3884613" y="0"/>
+            <a:ext cx="2971800" cy="457200"/>
+          </a:xfrm>
+          <a:prstGeom prst="rect">
+            <a:avLst/>
+          </a:prstGeom>
+        </p:spPr>
+        <p:txBody>
+          <a:bodyPr vert="horz" lIns="91440" tIns="45720" rIns="91440" bIns="45720" rtlCol="0"/>
+          <a:lstStyle>
+            <a:lvl1pPr algn="r">
+              <a:defRPr sz="1200"/>
+            </a:lvl1pPr>
+          </a:lstStyle>
+          <a:p>
+            <a:fld id="{0F89C1C7-3DCD-1040-A9CF-14679D8B5DDD}" type="datetimeFigureOut">
+              <a:rPr lang="en-US" smtClean="0"/>
+              <a:t>10/17/16</a:t>
+            </a:fld>
+            <a:endParaRPr lang="en-US"/>
+          </a:p>
+        </p:txBody>
+      </p:sp>
+      <p:sp>
+        <p:nvSpPr>
+          <p:cNvPr id="4" name="Slide Image Placeholder 3"/>
+          <p:cNvSpPr>
+            <a:spLocks noGrp="1" noRot="1" noChangeAspect="1"/>
+          </p:cNvSpPr>
+          <p:nvPr>
+            <p:ph type="sldImg" idx="2"/>
+          </p:nvPr>
+        </p:nvSpPr>
+        <p:spPr>
+          <a:xfrm>
+            <a:off x="1143000" y="685800"/>
+            <a:ext cx="4572000" cy="3429000"/>
+          </a:xfrm>
+          <a:prstGeom prst="rect">
+            <a:avLst/>
+          </a:prstGeom>
+          <a:noFill/>
+          <a:ln w="12700">
+            <a:solidFill>
+              <a:prstClr val="black"/>
+            </a:solidFill>
+          </a:ln>
+        </p:spPr>
+        <p:txBody>
+          <a:bodyPr vert="horz" lIns="91440" tIns="45720" rIns="91440" bIns="45720" rtlCol="0" anchor="ctr"/>
+          <a:lstStyle/>
+          <a:p>
+            <a:endParaRPr lang="en-US"/>
+          </a:p>
+        </p:txBody>
+      </p:sp>
+      <p:sp>
+        <p:nvSpPr>
+          <p:cNvPr id="5" name="Notes Placeholder 4"/>
+          <p:cNvSpPr>
+            <a:spLocks noGrp="1"/>
+          </p:cNvSpPr>
+          <p:nvPr>
+            <p:ph type="body" sz="quarter" idx="3"/>
+          </p:nvPr>
+        </p:nvSpPr>
+        <p:spPr>
+          <a:xfrm>
+            <a:off x="685800" y="4343400"/>
+            <a:ext cx="5486400" cy="4114800"/>
+          </a:xfrm>
+          <a:prstGeom prst="rect">
+            <a:avLst/>
+          </a:prstGeom>
+        </p:spPr>
+        <p:txBody>
+          <a:bodyPr vert="horz" lIns="91440" tIns="45720" rIns="91440" bIns="45720" rtlCol="0"/>
+          <a:lstStyle/>
+          <a:p>
+            <a:pPr lvl="0"/>
+            <a:r>
+              <a:rPr lang="en-US" smtClean="0"/>
+              <a:t>Click to edit Master text styles</a:t>
+            </a:r>
+          </a:p>
+          <a:p>
+            <a:pPr lvl="1"/>
+            <a:r>
+              <a:rPr lang="en-US" smtClean="0"/>
+              <a:t>Second level</a:t>
+            </a:r>
+          </a:p>
+          <a:p>
+            <a:pPr lvl="2"/>
+            <a:r>
+              <a:rPr lang="en-US" smtClean="0"/>
+              <a:t>Third level</a:t>
+            </a:r>
+          </a:p>
+          <a:p>
+            <a:pPr lvl="3"/>
+            <a:r>
+              <a:rPr lang="en-US" smtClean="0"/>
+              <a:t>Fourth level</a:t>
+            </a:r>
+          </a:p>
+          <a:p>
+            <a:pPr lvl="4"/>
+            <a:r>
+              <a:rPr lang="en-US" smtClean="0"/>
+              <a:t>Fifth level</a:t>
+            </a:r>
+            <a:endParaRPr lang="en-US"/>
+          </a:p>
+        </p:txBody>
+      </p:sp>
+      <p:sp>
+        <p:nvSpPr>
+          <p:cNvPr id="6" name="Footer Placeholder 5"/>
+          <p:cNvSpPr>
+            <a:spLocks noGrp="1"/>
+          </p:cNvSpPr>
+          <p:nvPr>
+            <p:ph type="ftr" sz="quarter" idx="4"/>
+          </p:nvPr>
+        </p:nvSpPr>
+        <p:spPr>
+          <a:xfrm>
+            <a:off x="0" y="8685213"/>
+            <a:ext cx="2971800" cy="457200"/>
+          </a:xfrm>
+          <a:prstGeom prst="rect">
+            <a:avLst/>
+          </a:prstGeom>
+        </p:spPr>
+        <p:txBody>
+          <a:bodyPr vert="horz" lIns="91440" tIns="45720" rIns="91440" bIns="45720" rtlCol="0" anchor="b"/>
+          <a:lstStyle>
+            <a:lvl1pPr algn="l">
+              <a:defRPr sz="1200"/>
+            </a:lvl1pPr>
+          </a:lstStyle>
+          <a:p>
+            <a:endParaRPr lang="en-US"/>
+          </a:p>
+        </p:txBody>
+      </p:sp>
+      <p:sp>
+        <p:nvSpPr>
+          <p:cNvPr id="7" name="Slide Number Placeholder 6"/>
+          <p:cNvSpPr>
+            <a:spLocks noGrp="1"/>
+          </p:cNvSpPr>
+          <p:nvPr>
+            <p:ph type="sldNum" sz="quarter" idx="5"/>
+          </p:nvPr>
+        </p:nvSpPr>
+        <p:spPr>
+          <a:xfrm>
+            <a:off x="3884613" y="8685213"/>
+            <a:ext cx="2971800" cy="457200"/>
+          </a:xfrm>
+          <a:prstGeom prst="rect">
+            <a:avLst/>
+          </a:prstGeom>
+        </p:spPr>
+        <p:txBody>
+          <a:bodyPr vert="horz" lIns="91440" tIns="45720" rIns="91440" bIns="45720" rtlCol="0" anchor="b"/>
+          <a:lstStyle>
+            <a:lvl1pPr algn="r">
+              <a:defRPr sz="1200"/>
+            </a:lvl1pPr>
+          </a:lstStyle>
+          <a:p>
+            <a:fld id="{BB5E49A5-4136-284D-997B-48E1D791AD67}" type="slidenum">
+              <a:rPr lang="en-US" smtClean="0"/>
+              <a:t>‹#›</a:t>
+            </a:fld>
+            <a:endParaRPr lang="en-US"/>
+          </a:p>
+        </p:txBody>
+      </p:sp>
+    </p:spTree>
+    <p:extLst>
+      <p:ext uri="{BB962C8B-B14F-4D97-AF65-F5344CB8AC3E}">
+        <p14:creationId xmlns:p14="http://schemas.microsoft.com/office/powerpoint/2010/main" val="2623252185"/>
+      </p:ext>
+    </p:extLst>
+  </p:cSld>
+  <p:clrMap bg1="lt1" tx1="dk1" bg2="lt2" tx2="dk2" accent1="accent1" accent2="accent2" accent3="accent3" accent4="accent4" accent5="accent5" accent6="accent6" hlink="hlink" folHlink="folHlink"/>
+  <p:notesStyle>
+    <a:lvl1pPr marL="0" algn="l" defTabSz="457200" rtl="0" eaLnBrk="1" latinLnBrk="0" hangingPunct="1">
+      <a:defRPr sz="1200" kern="1200">
+        <a:solidFill>
+          <a:schemeClr val="tx1"/>
+        </a:solidFill>
+        <a:latin typeface="+mn-lt"/>
+        <a:ea typeface="+mn-ea"/>
+        <a:cs typeface="+mn-cs"/>
+      </a:defRPr>
+    </a:lvl1pPr>
+    <a:lvl2pPr marL="457200" algn="l" defTabSz="457200" rtl="0" eaLnBrk="1" latinLnBrk="0" hangingPunct="1">
+      <a:defRPr sz="1200" kern="1200">
+        <a:solidFill>
+          <a:schemeClr val="tx1"/>
+        </a:solidFill>
+        <a:latin typeface="+mn-lt"/>
+        <a:ea typeface="+mn-ea"/>
+        <a:cs typeface="+mn-cs"/>
+      </a:defRPr>
+    </a:lvl2pPr>
+    <a:lvl3pPr marL="914400" algn="l" defTabSz="457200" rtl="0" eaLnBrk="1" latinLnBrk="0" hangingPunct="1">
+      <a:defRPr sz="1200" kern="1200">
+        <a:solidFill>
+          <a:schemeClr val="tx1"/>
+        </a:solidFill>
+        <a:latin typeface="+mn-lt"/>
+        <a:ea typeface="+mn-ea"/>
+        <a:cs typeface="+mn-cs"/>
+      </a:defRPr>
+    </a:lvl3pPr>
+    <a:lvl4pPr marL="1371600" algn="l" defTabSz="457200" rtl="0" eaLnBrk="1" latinLnBrk="0" hangingPunct="1">
+      <a:defRPr sz="1200" kern="1200">
+        <a:solidFill>
+          <a:schemeClr val="tx1"/>
+        </a:solidFill>
+        <a:latin typeface="+mn-lt"/>
+        <a:ea typeface="+mn-ea"/>
+        <a:cs typeface="+mn-cs"/>
+      </a:defRPr>
+    </a:lvl4pPr>
+    <a:lvl5pPr marL="1828800" algn="l" defTabSz="457200" rtl="0" eaLnBrk="1" latinLnBrk="0" hangingPunct="1">
+      <a:defRPr sz="1200" kern="1200">
+        <a:solidFill>
+          <a:schemeClr val="tx1"/>
+        </a:solidFill>
+        <a:latin typeface="+mn-lt"/>
+        <a:ea typeface="+mn-ea"/>
+        <a:cs typeface="+mn-cs"/>
+      </a:defRPr>
+    </a:lvl5pPr>
+    <a:lvl6pPr marL="2286000" algn="l" defTabSz="457200" rtl="0" eaLnBrk="1" latinLnBrk="0" hangingPunct="1">
+      <a:defRPr sz="1200" kern="1200">
+        <a:solidFill>
+          <a:schemeClr val="tx1"/>
+        </a:solidFill>
+        <a:latin typeface="+mn-lt"/>
+        <a:ea typeface="+mn-ea"/>
+        <a:cs typeface="+mn-cs"/>
+      </a:defRPr>
+    </a:lvl6pPr>
+    <a:lvl7pPr marL="2743200" algn="l" defTabSz="457200" rtl="0" eaLnBrk="1" latinLnBrk="0" hangingPunct="1">
+      <a:defRPr sz="1200" kern="1200">
+        <a:solidFill>
+          <a:schemeClr val="tx1"/>
+        </a:solidFill>
+        <a:latin typeface="+mn-lt"/>
+        <a:ea typeface="+mn-ea"/>
+        <a:cs typeface="+mn-cs"/>
+      </a:defRPr>
+    </a:lvl7pPr>
+    <a:lvl8pPr marL="3200400" algn="l" defTabSz="457200" rtl="0" eaLnBrk="1" latinLnBrk="0" hangingPunct="1">
+      <a:defRPr sz="1200" kern="1200">
+        <a:solidFill>
+          <a:schemeClr val="tx1"/>
+        </a:solidFill>
+        <a:latin typeface="+mn-lt"/>
+        <a:ea typeface="+mn-ea"/>
+        <a:cs typeface="+mn-cs"/>
+      </a:defRPr>
+    </a:lvl8pPr>
+    <a:lvl9pPr marL="3657600" algn="l" defTabSz="457200" rtl="0" eaLnBrk="1" latinLnBrk="0" hangingPunct="1">
+      <a:defRPr sz="1200" kern="1200">
+        <a:solidFill>
+          <a:schemeClr val="tx1"/>
+        </a:solidFill>
+        <a:latin typeface="+mn-lt"/>
+        <a:ea typeface="+mn-ea"/>
+        <a:cs typeface="+mn-cs"/>
+      </a:defRPr>
+    </a:lvl9pPr>
+  </p:notesStyle>
+</p:notesMaster>
+</file>
+
+<file path=ppt/notesSlides/notesSlide1.xml><?xml version="1.0" encoding="utf-8"?>
+<p:notes xmlns:a="http://schemas.openxmlformats.org/drawingml/2006/main" xmlns:p="http://schemas.openxmlformats.org/presentationml/2006/main" xmlns:r="http://schemas.openxmlformats.org/officeDocument/2006/relationships">
+  <p:cSld>
+    <p:spTree>
+      <p:nvGrpSpPr>
+        <p:cNvPr id="1" name=""/>
+        <p:cNvGrpSpPr/>
+        <p:nvPr/>
+      </p:nvGrpSpPr>
+      <p:grpSpPr>
+        <a:xfrm>
+          <a:off x="0" y="0"/>
+          <a:ext cx="0" cy="0"/>
+          <a:chOff x="0" y="0"/>
+          <a:chExt cx="0" cy="0"/>
+        </a:xfrm>
+      </p:grpSpPr>
+      <p:sp>
+        <p:nvSpPr>
+          <p:cNvPr id="2" name="Slide Image Placeholder 1"/>
+          <p:cNvSpPr>
+            <a:spLocks noGrp="1"/>
+          </p:cNvSpPr>
+          <p:nvPr>
+            <p:ph type="sldImg" idx="2"/>
+          </p:nvPr>
+        </p:nvSpPr>
+        <p:spPr/>
+      </p:sp>
+      <p:sp>
+        <p:nvSpPr>
+          <p:cNvPr id="3" name="Notes Placeholder 2"/>
+          <p:cNvSpPr>
+            <a:spLocks noGrp="1"/>
+          </p:cNvSpPr>
+          <p:nvPr>
+            <p:ph type="body" idx="3" sz="quarter"/>
+          </p:nvPr>
+        </p:nvSpPr>
+        <p:spPr/>
+        <p:txBody>
+          <a:bodyPr/>
+          <a:lstStyle/>
+          <a:p>
+            <a:r>
+              <a:t>Open here, in one breath. I didn't build one agent — I built the layer that makes all of them possible. A CDP tells you WHO the customer is; this tells the agent WHAT it needs to act, right now. Don't read the slide — say this line and move.</a:t>
+            </a:r>
+          </a:p>
+        </p:txBody>
+      </p:sp>
+      <p:sp>
+        <p:nvSpPr>
+          <p:cNvPr id="4" name="Slide Number Placeholder 3"/>
+          <p:cNvSpPr>
+            <a:spLocks noGrp="1"/>
+          </p:cNvSpPr>
+          <p:nvPr>
+            <p:ph type="sldNum" idx="5" sz="quarter"/>
+          </p:nvPr>
+        </p:nvSpPr>
+        <p:spPr/>
+      </p:sp>
+    </p:spTree>
+  </p:cSld>
+  <p:clrMapOvr>
+    <a:masterClrMapping/>
+  </p:clrMapOvr>
+</p:notes>
+</file>
+
+<file path=ppt/notesSlides/notesSlide10.xml><?xml version="1.0" encoding="utf-8"?>
+<p:notes xmlns:a="http://schemas.openxmlformats.org/drawingml/2006/main" xmlns:p="http://schemas.openxmlformats.org/presentationml/2006/main" xmlns:r="http://schemas.openxmlformats.org/officeDocument/2006/relationships">
+  <p:cSld>
+    <p:spTree>
+      <p:nvGrpSpPr>
+        <p:cNvPr id="1" name=""/>
+        <p:cNvGrpSpPr/>
+        <p:nvPr/>
+      </p:nvGrpSpPr>
+      <p:grpSpPr>
+        <a:xfrm>
+          <a:off x="0" y="0"/>
+          <a:ext cx="0" cy="0"/>
+          <a:chOff x="0" y="0"/>
+          <a:chExt cx="0" cy="0"/>
+        </a:xfrm>
+      </p:grpSpPr>
+      <p:sp>
+        <p:nvSpPr>
+          <p:cNvPr id="2" name="Slide Image Placeholder 1"/>
+          <p:cNvSpPr>
+            <a:spLocks noGrp="1"/>
+          </p:cNvSpPr>
+          <p:nvPr>
+            <p:ph type="sldImg" idx="2"/>
+          </p:nvPr>
+        </p:nvSpPr>
+        <p:spPr/>
+      </p:sp>
+      <p:sp>
+        <p:nvSpPr>
+          <p:cNvPr id="3" name="Notes Placeholder 2"/>
+          <p:cNvSpPr>
+            <a:spLocks noGrp="1"/>
+          </p:cNvSpPr>
+          <p:nvPr>
+            <p:ph type="body" idx="3" sz="quarter"/>
+          </p:nvPr>
+        </p:nvSpPr>
+        <p:spPr/>
+        <p:txBody>
+          <a:bodyPr/>
+          <a:lstStyle/>
+          <a:p>
+            <a:r>
+              <a:t>Six agents today, then the new stuff brands can't do alone: anticipatory, self-tuning, cross-brand cold-start. The point — these aren't separate products; they're contracts on one layer.</a:t>
+            </a:r>
+          </a:p>
+        </p:txBody>
+      </p:sp>
+      <p:sp>
+        <p:nvSpPr>
+          <p:cNvPr id="4" name="Slide Number Placeholder 3"/>
+          <p:cNvSpPr>
+            <a:spLocks noGrp="1"/>
+          </p:cNvSpPr>
+          <p:nvPr>
+            <p:ph type="sldNum" idx="5" sz="quarter"/>
+          </p:nvPr>
+        </p:nvSpPr>
+        <p:spPr/>
+      </p:sp>
+    </p:spTree>
+  </p:cSld>
+  <p:clrMapOvr>
+    <a:masterClrMapping/>
+  </p:clrMapOvr>
+</p:notes>
+</file>
+
+<file path=ppt/notesSlides/notesSlide11.xml><?xml version="1.0" encoding="utf-8"?>
+<p:notes xmlns:a="http://schemas.openxmlformats.org/drawingml/2006/main" xmlns:p="http://schemas.openxmlformats.org/presentationml/2006/main" xmlns:r="http://schemas.openxmlformats.org/officeDocument/2006/relationships">
+  <p:cSld>
+    <p:spTree>
+      <p:nvGrpSpPr>
+        <p:cNvPr id="1" name=""/>
+        <p:cNvGrpSpPr/>
+        <p:nvPr/>
+      </p:nvGrpSpPr>
+      <p:grpSpPr>
+        <a:xfrm>
+          <a:off x="0" y="0"/>
+          <a:ext cx="0" cy="0"/>
+          <a:chOff x="0" y="0"/>
+          <a:chExt cx="0" cy="0"/>
+        </a:xfrm>
+      </p:grpSpPr>
+      <p:sp>
+        <p:nvSpPr>
+          <p:cNvPr id="2" name="Slide Image Placeholder 1"/>
+          <p:cNvSpPr>
+            <a:spLocks noGrp="1"/>
+          </p:cNvSpPr>
+          <p:nvPr>
+            <p:ph type="sldImg" idx="2"/>
+          </p:nvPr>
+        </p:nvSpPr>
+        <p:spPr/>
+      </p:sp>
+      <p:sp>
+        <p:nvSpPr>
+          <p:cNvPr id="3" name="Notes Placeholder 2"/>
+          <p:cNvSpPr>
+            <a:spLocks noGrp="1"/>
+          </p:cNvSpPr>
+          <p:nvPr>
+            <p:ph type="body" idx="3" sz="quarter"/>
+          </p:nvPr>
+        </p:nvSpPr>
+        <p:spPr/>
+        <p:txBody>
+          <a:bodyPr/>
+          <a:lstStyle/>
+          <a:p>
+            <a:r>
+              <a:t>The strongest slide — slow down. One brand sees one return; annoying. WE see four of five across three brands; that's a pattern. We pause COD before shipping at a loss. No single brand can build this, and every new brand makes the priors better for everyone. That's the moat — the data layer is the network effect, not a cost center.</a:t>
+            </a:r>
+          </a:p>
+        </p:txBody>
+      </p:sp>
+      <p:sp>
+        <p:nvSpPr>
+          <p:cNvPr id="4" name="Slide Number Placeholder 3"/>
+          <p:cNvSpPr>
+            <a:spLocks noGrp="1"/>
+          </p:cNvSpPr>
+          <p:nvPr>
+            <p:ph type="sldNum" idx="5" sz="quarter"/>
+          </p:nvPr>
+        </p:nvSpPr>
+        <p:spPr/>
+      </p:sp>
+    </p:spTree>
+  </p:cSld>
+  <p:clrMapOvr>
+    <a:masterClrMapping/>
+  </p:clrMapOvr>
+</p:notes>
+</file>
+
+<file path=ppt/notesSlides/notesSlide12.xml><?xml version="1.0" encoding="utf-8"?>
+<p:notes xmlns:a="http://schemas.openxmlformats.org/drawingml/2006/main" xmlns:p="http://schemas.openxmlformats.org/presentationml/2006/main" xmlns:r="http://schemas.openxmlformats.org/officeDocument/2006/relationships">
+  <p:cSld>
+    <p:spTree>
+      <p:nvGrpSpPr>
+        <p:cNvPr id="1" name=""/>
+        <p:cNvGrpSpPr/>
+        <p:nvPr/>
+      </p:nvGrpSpPr>
+      <p:grpSpPr>
+        <a:xfrm>
+          <a:off x="0" y="0"/>
+          <a:ext cx="0" cy="0"/>
+          <a:chOff x="0" y="0"/>
+          <a:chExt cx="0" cy="0"/>
+        </a:xfrm>
+      </p:grpSpPr>
+      <p:sp>
+        <p:nvSpPr>
+          <p:cNvPr id="2" name="Slide Image Placeholder 1"/>
+          <p:cNvSpPr>
+            <a:spLocks noGrp="1"/>
+          </p:cNvSpPr>
+          <p:nvPr>
+            <p:ph type="sldImg" idx="2"/>
+          </p:nvPr>
+        </p:nvSpPr>
+        <p:spPr/>
+      </p:sp>
+      <p:sp>
+        <p:nvSpPr>
+          <p:cNvPr id="3" name="Notes Placeholder 2"/>
+          <p:cNvSpPr>
+            <a:spLocks noGrp="1"/>
+          </p:cNvSpPr>
+          <p:nvPr>
+            <p:ph type="body" idx="3" sz="quarter"/>
+          </p:nvPr>
+        </p:nvSpPr>
+        <p:spPr/>
+        <p:txBody>
+          <a:bodyPr/>
+          <a:lstStyle/>
+          <a:p>
+            <a:r>
+              <a:t>This is how it scales. New product equals a new contract over existing traits. No re-architecture. A new trait, computed once, is available to every future agent. Platform cost stays roughly flat per product — the roadmap speeds up as it grows, instead of bogging down.</a:t>
+            </a:r>
+          </a:p>
+        </p:txBody>
+      </p:sp>
+      <p:sp>
+        <p:nvSpPr>
+          <p:cNvPr id="4" name="Slide Number Placeholder 3"/>
+          <p:cNvSpPr>
+            <a:spLocks noGrp="1"/>
+          </p:cNvSpPr>
+          <p:nvPr>
+            <p:ph type="sldNum" idx="5" sz="quarter"/>
+          </p:nvPr>
+        </p:nvSpPr>
+        <p:spPr/>
+      </p:sp>
+    </p:spTree>
+  </p:cSld>
+  <p:clrMapOvr>
+    <a:masterClrMapping/>
+  </p:clrMapOvr>
+</p:notes>
+</file>
+
+<file path=ppt/notesSlides/notesSlide13.xml><?xml version="1.0" encoding="utf-8"?>
+<p:notes xmlns:a="http://schemas.openxmlformats.org/drawingml/2006/main" xmlns:p="http://schemas.openxmlformats.org/presentationml/2006/main" xmlns:r="http://schemas.openxmlformats.org/officeDocument/2006/relationships">
+  <p:cSld>
+    <p:spTree>
+      <p:nvGrpSpPr>
+        <p:cNvPr id="1" name=""/>
+        <p:cNvGrpSpPr/>
+        <p:nvPr/>
+      </p:nvGrpSpPr>
+      <p:grpSpPr>
+        <a:xfrm>
+          <a:off x="0" y="0"/>
+          <a:ext cx="0" cy="0"/>
+          <a:chOff x="0" y="0"/>
+          <a:chExt cx="0" cy="0"/>
+        </a:xfrm>
+      </p:grpSpPr>
+      <p:sp>
+        <p:nvSpPr>
+          <p:cNvPr id="2" name="Slide Image Placeholder 1"/>
+          <p:cNvSpPr>
+            <a:spLocks noGrp="1"/>
+          </p:cNvSpPr>
+          <p:nvPr>
+            <p:ph type="sldImg" idx="2"/>
+          </p:nvPr>
+        </p:nvSpPr>
+        <p:spPr/>
+      </p:sp>
+      <p:sp>
+        <p:nvSpPr>
+          <p:cNvPr id="3" name="Notes Placeholder 2"/>
+          <p:cNvSpPr>
+            <a:spLocks noGrp="1"/>
+          </p:cNvSpPr>
+          <p:nvPr>
+            <p:ph type="body" idx="3" sz="quarter"/>
+          </p:nvPr>
+        </p:nvSpPr>
+        <p:spPr/>
+        <p:txBody>
+          <a:bodyPr/>
+          <a:lstStyle/>
+          <a:p>
+            <a:r>
+              <a:t>The unglamorous part that decides if it's real. Brand-isolated by default; cross-brand shares derived SCORES, never raw PII. DPDP-aware. Auditable, because traits recompute from the event log.</a:t>
+            </a:r>
+          </a:p>
+        </p:txBody>
+      </p:sp>
+      <p:sp>
+        <p:nvSpPr>
+          <p:cNvPr id="4" name="Slide Number Placeholder 3"/>
+          <p:cNvSpPr>
+            <a:spLocks noGrp="1"/>
+          </p:cNvSpPr>
+          <p:nvPr>
+            <p:ph type="sldNum" idx="5" sz="quarter"/>
+          </p:nvPr>
+        </p:nvSpPr>
+        <p:spPr/>
+      </p:sp>
+    </p:spTree>
+  </p:cSld>
+  <p:clrMapOvr>
+    <a:masterClrMapping/>
+  </p:clrMapOvr>
+</p:notes>
+</file>
+
+<file path=ppt/notesSlides/notesSlide14.xml><?xml version="1.0" encoding="utf-8"?>
+<p:notes xmlns:a="http://schemas.openxmlformats.org/drawingml/2006/main" xmlns:p="http://schemas.openxmlformats.org/presentationml/2006/main" xmlns:r="http://schemas.openxmlformats.org/officeDocument/2006/relationships">
+  <p:cSld>
+    <p:spTree>
+      <p:nvGrpSpPr>
+        <p:cNvPr id="1" name=""/>
+        <p:cNvGrpSpPr/>
+        <p:nvPr/>
+      </p:nvGrpSpPr>
+      <p:grpSpPr>
+        <a:xfrm>
+          <a:off x="0" y="0"/>
+          <a:ext cx="0" cy="0"/>
+          <a:chOff x="0" y="0"/>
+          <a:chExt cx="0" cy="0"/>
+        </a:xfrm>
+      </p:grpSpPr>
+      <p:sp>
+        <p:nvSpPr>
+          <p:cNvPr id="2" name="Slide Image Placeholder 1"/>
+          <p:cNvSpPr>
+            <a:spLocks noGrp="1"/>
+          </p:cNvSpPr>
+          <p:nvPr>
+            <p:ph type="sldImg" idx="2"/>
+          </p:nvPr>
+        </p:nvSpPr>
+        <p:spPr/>
+      </p:sp>
+      <p:sp>
+        <p:nvSpPr>
+          <p:cNvPr id="3" name="Notes Placeholder 2"/>
+          <p:cNvSpPr>
+            <a:spLocks noGrp="1"/>
+          </p:cNvSpPr>
+          <p:nvPr>
+            <p:ph type="body" idx="3" sz="quarter"/>
+          </p:nvPr>
+        </p:nvSpPr>
+        <p:spPr/>
+        <p:txBody>
+          <a:bodyPr/>
+          <a:lstStyle/>
+          <a:p>
+            <a:r>
+              <a:t>Criterion five. Foundation first — nothing works without identity and the stores. Then low-regret, clean-data agents: WIMO, cart, COD-to-prepaid. I order by value times data-readiness times reversibility of risk.</a:t>
+            </a:r>
+          </a:p>
+        </p:txBody>
+      </p:sp>
+      <p:sp>
+        <p:nvSpPr>
+          <p:cNvPr id="4" name="Slide Number Placeholder 3"/>
+          <p:cNvSpPr>
+            <a:spLocks noGrp="1"/>
+          </p:cNvSpPr>
+          <p:nvPr>
+            <p:ph type="sldNum" idx="5" sz="quarter"/>
+          </p:nvPr>
+        </p:nvSpPr>
+        <p:spPr/>
+      </p:sp>
+    </p:spTree>
+  </p:cSld>
+  <p:clrMapOvr>
+    <a:masterClrMapping/>
+  </p:clrMapOvr>
+</p:notes>
+</file>
+
+<file path=ppt/notesSlides/notesSlide15.xml><?xml version="1.0" encoding="utf-8"?>
+<p:notes xmlns:a="http://schemas.openxmlformats.org/drawingml/2006/main" xmlns:p="http://schemas.openxmlformats.org/presentationml/2006/main" xmlns:r="http://schemas.openxmlformats.org/officeDocument/2006/relationships">
+  <p:cSld>
+    <p:spTree>
+      <p:nvGrpSpPr>
+        <p:cNvPr id="1" name=""/>
+        <p:cNvGrpSpPr/>
+        <p:nvPr/>
+      </p:nvGrpSpPr>
+      <p:grpSpPr>
+        <a:xfrm>
+          <a:off x="0" y="0"/>
+          <a:ext cx="0" cy="0"/>
+          <a:chOff x="0" y="0"/>
+          <a:chExt cx="0" cy="0"/>
+        </a:xfrm>
+      </p:grpSpPr>
+      <p:sp>
+        <p:nvSpPr>
+          <p:cNvPr id="2" name="Slide Image Placeholder 1"/>
+          <p:cNvSpPr>
+            <a:spLocks noGrp="1"/>
+          </p:cNvSpPr>
+          <p:nvPr>
+            <p:ph type="sldImg" idx="2"/>
+          </p:nvPr>
+        </p:nvSpPr>
+        <p:spPr/>
+      </p:sp>
+      <p:sp>
+        <p:nvSpPr>
+          <p:cNvPr id="3" name="Notes Placeholder 2"/>
+          <p:cNvSpPr>
+            <a:spLocks noGrp="1"/>
+          </p:cNvSpPr>
+          <p:nvPr>
+            <p:ph type="body" idx="3" sz="quarter"/>
+          </p:nvPr>
+        </p:nvSpPr>
+        <p:spPr/>
+        <p:txBody>
+          <a:bodyPr/>
+          <a:lstStyle/>
+          <a:p>
+            <a:r>
+              <a:t>Just as important — what I'd cut, and why. Autonomous send, broad broadcasts, returns adjudication, ML retraining infra — high blast radius or money-and-policy. Earn trust first. The restraint is the signal: the prototype itself has no DB, no auth, on purpose.</a:t>
+            </a:r>
+          </a:p>
+        </p:txBody>
+      </p:sp>
+      <p:sp>
+        <p:nvSpPr>
+          <p:cNvPr id="4" name="Slide Number Placeholder 3"/>
+          <p:cNvSpPr>
+            <a:spLocks noGrp="1"/>
+          </p:cNvSpPr>
+          <p:nvPr>
+            <p:ph type="sldNum" idx="5" sz="quarter"/>
+          </p:nvPr>
+        </p:nvSpPr>
+        <p:spPr/>
+      </p:sp>
+    </p:spTree>
+  </p:cSld>
+  <p:clrMapOvr>
+    <a:masterClrMapping/>
+  </p:clrMapOvr>
+</p:notes>
+</file>
+
+<file path=ppt/notesSlides/notesSlide16.xml><?xml version="1.0" encoding="utf-8"?>
+<p:notes xmlns:a="http://schemas.openxmlformats.org/drawingml/2006/main" xmlns:p="http://schemas.openxmlformats.org/presentationml/2006/main" xmlns:r="http://schemas.openxmlformats.org/officeDocument/2006/relationships">
+  <p:cSld>
+    <p:spTree>
+      <p:nvGrpSpPr>
+        <p:cNvPr id="1" name=""/>
+        <p:cNvGrpSpPr/>
+        <p:nvPr/>
+      </p:nvGrpSpPr>
+      <p:grpSpPr>
+        <a:xfrm>
+          <a:off x="0" y="0"/>
+          <a:ext cx="0" cy="0"/>
+          <a:chOff x="0" y="0"/>
+          <a:chExt cx="0" cy="0"/>
+        </a:xfrm>
+      </p:grpSpPr>
+      <p:sp>
+        <p:nvSpPr>
+          <p:cNvPr id="2" name="Slide Image Placeholder 1"/>
+          <p:cNvSpPr>
+            <a:spLocks noGrp="1"/>
+          </p:cNvSpPr>
+          <p:nvPr>
+            <p:ph type="sldImg" idx="2"/>
+          </p:nvPr>
+        </p:nvSpPr>
+        <p:spPr/>
+      </p:sp>
+      <p:sp>
+        <p:nvSpPr>
+          <p:cNvPr id="3" name="Notes Placeholder 2"/>
+          <p:cNvSpPr>
+            <a:spLocks noGrp="1"/>
+          </p:cNvSpPr>
+          <p:nvPr>
+            <p:ph type="body" idx="3" sz="quarter"/>
+          </p:nvPr>
+        </p:nvSpPr>
+        <p:spPr/>
+        <p:txBody>
+          <a:bodyPr/>
+          <a:lstStyle/>
+          <a:p>
+            <a:r>
+              <a:t>Be honest. The real risks are identity false-merges and cold-start for tiny brands. Mitigations: confidence thresholds plus human review; platform-wide priors plus conservative actions until a brand has volume.</a:t>
+            </a:r>
+          </a:p>
+        </p:txBody>
+      </p:sp>
+      <p:sp>
+        <p:nvSpPr>
+          <p:cNvPr id="4" name="Slide Number Placeholder 3"/>
+          <p:cNvSpPr>
+            <a:spLocks noGrp="1"/>
+          </p:cNvSpPr>
+          <p:nvPr>
+            <p:ph type="sldNum" idx="5" sz="quarter"/>
+          </p:nvPr>
+        </p:nvSpPr>
+        <p:spPr/>
+      </p:sp>
+    </p:spTree>
+  </p:cSld>
+  <p:clrMapOvr>
+    <a:masterClrMapping/>
+  </p:clrMapOvr>
+</p:notes>
+</file>
+
+<file path=ppt/notesSlides/notesSlide17.xml><?xml version="1.0" encoding="utf-8"?>
+<p:notes xmlns:a="http://schemas.openxmlformats.org/drawingml/2006/main" xmlns:p="http://schemas.openxmlformats.org/presentationml/2006/main" xmlns:r="http://schemas.openxmlformats.org/officeDocument/2006/relationships">
+  <p:cSld>
+    <p:spTree>
+      <p:nvGrpSpPr>
+        <p:cNvPr id="1" name=""/>
+        <p:cNvGrpSpPr/>
+        <p:nvPr/>
+      </p:nvGrpSpPr>
+      <p:grpSpPr>
+        <a:xfrm>
+          <a:off x="0" y="0"/>
+          <a:ext cx="0" cy="0"/>
+          <a:chOff x="0" y="0"/>
+          <a:chExt cx="0" cy="0"/>
+        </a:xfrm>
+      </p:grpSpPr>
+      <p:sp>
+        <p:nvSpPr>
+          <p:cNvPr id="2" name="Slide Image Placeholder 1"/>
+          <p:cNvSpPr>
+            <a:spLocks noGrp="1"/>
+          </p:cNvSpPr>
+          <p:nvPr>
+            <p:ph type="sldImg" idx="2"/>
+          </p:nvPr>
+        </p:nvSpPr>
+        <p:spPr/>
+      </p:sp>
+      <p:sp>
+        <p:nvSpPr>
+          <p:cNvPr id="3" name="Notes Placeholder 2"/>
+          <p:cNvSpPr>
+            <a:spLocks noGrp="1"/>
+          </p:cNvSpPr>
+          <p:nvPr>
+            <p:ph type="body" idx="3" sz="quarter"/>
+          </p:nvPr>
+        </p:nvSpPr>
+        <p:spPr/>
+        <p:txBody>
+          <a:bodyPr/>
+          <a:lstStyle/>
+          <a:p>
+            <a:r>
+              <a:t>Close on this, then stop. Today's agent gets smarter the day this ships; every future agent just declares a contract; across many brands the data compounds into a moat. Then the four reasons it's the RIGHT answer, not just an answer. End there.</a:t>
+            </a:r>
+          </a:p>
+        </p:txBody>
+      </p:sp>
+      <p:sp>
+        <p:nvSpPr>
+          <p:cNvPr id="4" name="Slide Number Placeholder 3"/>
+          <p:cNvSpPr>
+            <a:spLocks noGrp="1"/>
+          </p:cNvSpPr>
+          <p:nvPr>
+            <p:ph type="sldNum" idx="5" sz="quarter"/>
+          </p:nvPr>
+        </p:nvSpPr>
+        <p:spPr/>
+      </p:sp>
+    </p:spTree>
+  </p:cSld>
+  <p:clrMapOvr>
+    <a:masterClrMapping/>
+  </p:clrMapOvr>
+</p:notes>
+</file>
+
+<file path=ppt/notesSlides/notesSlide2.xml><?xml version="1.0" encoding="utf-8"?>
+<p:notes xmlns:a="http://schemas.openxmlformats.org/drawingml/2006/main" xmlns:p="http://schemas.openxmlformats.org/presentationml/2006/main" xmlns:r="http://schemas.openxmlformats.org/officeDocument/2006/relationships">
+  <p:cSld>
+    <p:spTree>
+      <p:nvGrpSpPr>
+        <p:cNvPr id="1" name=""/>
+        <p:cNvGrpSpPr/>
+        <p:nvPr/>
+      </p:nvGrpSpPr>
+      <p:grpSpPr>
+        <a:xfrm>
+          <a:off x="0" y="0"/>
+          <a:ext cx="0" cy="0"/>
+          <a:chOff x="0" y="0"/>
+          <a:chExt cx="0" cy="0"/>
+        </a:xfrm>
+      </p:grpSpPr>
+      <p:sp>
+        <p:nvSpPr>
+          <p:cNvPr id="2" name="Slide Image Placeholder 1"/>
+          <p:cNvSpPr>
+            <a:spLocks noGrp="1"/>
+          </p:cNvSpPr>
+          <p:nvPr>
+            <p:ph type="sldImg" idx="2"/>
+          </p:nvPr>
+        </p:nvSpPr>
+        <p:spPr/>
+      </p:sp>
+      <p:sp>
+        <p:nvSpPr>
+          <p:cNvPr id="3" name="Notes Placeholder 2"/>
+          <p:cNvSpPr>
+            <a:spLocks noGrp="1"/>
+          </p:cNvSpPr>
+          <p:nvPr>
+            <p:ph type="body" idx="3" sz="quarter"/>
+          </p:nvPr>
+        </p:nvSpPr>
+        <p:spPr/>
+        <p:txBody>
+          <a:bodyPr/>
+          <a:lstStyle/>
+          <a:p>
+            <a:r>
+              <a:t>Open here, in one breath. I didn't build one agent — I built the layer that makes all of them possible. A CDP tells you WHO the customer is; this tells the agent WHAT it needs to act, right now. Don't read the slide — say this line and move.</a:t>
+            </a:r>
+          </a:p>
+        </p:txBody>
+      </p:sp>
+      <p:sp>
+        <p:nvSpPr>
+          <p:cNvPr id="4" name="Slide Number Placeholder 3"/>
+          <p:cNvSpPr>
+            <a:spLocks noGrp="1"/>
+          </p:cNvSpPr>
+          <p:nvPr>
+            <p:ph type="sldNum" idx="5" sz="quarter"/>
+          </p:nvPr>
+        </p:nvSpPr>
+        <p:spPr/>
+      </p:sp>
+    </p:spTree>
+  </p:cSld>
+  <p:clrMapOvr>
+    <a:masterClrMapping/>
+  </p:clrMapOvr>
+</p:notes>
+</file>
+
+<file path=ppt/notesSlides/notesSlide3.xml><?xml version="1.0" encoding="utf-8"?>
+<p:notes xmlns:a="http://schemas.openxmlformats.org/drawingml/2006/main" xmlns:p="http://schemas.openxmlformats.org/presentationml/2006/main" xmlns:r="http://schemas.openxmlformats.org/officeDocument/2006/relationships">
+  <p:cSld>
+    <p:spTree>
+      <p:nvGrpSpPr>
+        <p:cNvPr id="1" name=""/>
+        <p:cNvGrpSpPr/>
+        <p:nvPr/>
+      </p:nvGrpSpPr>
+      <p:grpSpPr>
+        <a:xfrm>
+          <a:off x="0" y="0"/>
+          <a:ext cx="0" cy="0"/>
+          <a:chOff x="0" y="0"/>
+          <a:chExt cx="0" cy="0"/>
+        </a:xfrm>
+      </p:grpSpPr>
+      <p:sp>
+        <p:nvSpPr>
+          <p:cNvPr id="2" name="Slide Image Placeholder 1"/>
+          <p:cNvSpPr>
+            <a:spLocks noGrp="1"/>
+          </p:cNvSpPr>
+          <p:nvPr>
+            <p:ph type="sldImg" idx="2"/>
+          </p:nvPr>
+        </p:nvSpPr>
+        <p:spPr/>
+      </p:sp>
+      <p:sp>
+        <p:nvSpPr>
+          <p:cNvPr id="3" name="Notes Placeholder 2"/>
+          <p:cNvSpPr>
+            <a:spLocks noGrp="1"/>
+          </p:cNvSpPr>
+          <p:nvPr>
+            <p:ph type="body" idx="3" sz="quarter"/>
+          </p:nvPr>
+        </p:nvSpPr>
+        <p:spPr/>
+        <p:txBody>
+          <a:bodyPr/>
+          <a:lstStyle/>
+          <a:p>
+            <a:r>
+              <a:t>Velocity's data is scattered and the same person is several records. Ten products on the roadmap, and every single one fails the same way — it acts on partial context. So the bottleneck isn't the agents; it's the context underneath them. Pause on that.</a:t>
+            </a:r>
+          </a:p>
+        </p:txBody>
+      </p:sp>
+      <p:sp>
+        <p:nvSpPr>
+          <p:cNvPr id="4" name="Slide Number Placeholder 3"/>
+          <p:cNvSpPr>
+            <a:spLocks noGrp="1"/>
+          </p:cNvSpPr>
+          <p:nvPr>
+            <p:ph type="sldNum" idx="5" sz="quarter"/>
+          </p:nvPr>
+        </p:nvSpPr>
+        <p:spPr/>
+      </p:sp>
+    </p:spTree>
+  </p:cSld>
+  <p:clrMapOvr>
+    <a:masterClrMapping/>
+  </p:clrMapOvr>
+</p:notes>
+</file>
+
+<file path=ppt/notesSlides/notesSlide4.xml><?xml version="1.0" encoding="utf-8"?>
+<p:notes xmlns:a="http://schemas.openxmlformats.org/drawingml/2006/main" xmlns:p="http://schemas.openxmlformats.org/presentationml/2006/main" xmlns:r="http://schemas.openxmlformats.org/officeDocument/2006/relationships">
+  <p:cSld>
+    <p:spTree>
+      <p:nvGrpSpPr>
+        <p:cNvPr id="1" name=""/>
+        <p:cNvGrpSpPr/>
+        <p:nvPr/>
+      </p:nvGrpSpPr>
+      <p:grpSpPr>
+        <a:xfrm>
+          <a:off x="0" y="0"/>
+          <a:ext cx="0" cy="0"/>
+          <a:chOff x="0" y="0"/>
+          <a:chExt cx="0" cy="0"/>
+        </a:xfrm>
+      </p:grpSpPr>
+      <p:sp>
+        <p:nvSpPr>
+          <p:cNvPr id="2" name="Slide Image Placeholder 1"/>
+          <p:cNvSpPr>
+            <a:spLocks noGrp="1"/>
+          </p:cNvSpPr>
+          <p:nvPr>
+            <p:ph type="sldImg" idx="2"/>
+          </p:nvPr>
+        </p:nvSpPr>
+        <p:spPr/>
+      </p:sp>
+      <p:sp>
+        <p:nvSpPr>
+          <p:cNvPr id="3" name="Notes Placeholder 2"/>
+          <p:cNvSpPr>
+            <a:spLocks noGrp="1"/>
+          </p:cNvSpPr>
+          <p:nvPr>
+            <p:ph type="body" idx="3" sz="quarter"/>
+          </p:nvPr>
+        </p:nvSpPr>
+        <p:spPr/>
+        <p:txBody>
+          <a:bodyPr/>
+          <a:lstStyle/>
+          <a:p>
+            <a:r>
+              <a:t>This is THE key slide. CDP is profile-first — one big record. We're job-first — a tight bundle per task. And I didn't design the schema in a vacuum: I let the agents' NEEDS be the forcing function. Each agent declares what it needs; that defines the layer. That's why it serves products we haven't built yet.</a:t>
+            </a:r>
+          </a:p>
+        </p:txBody>
+      </p:sp>
+      <p:sp>
+        <p:nvSpPr>
+          <p:cNvPr id="4" name="Slide Number Placeholder 3"/>
+          <p:cNvSpPr>
+            <a:spLocks noGrp="1"/>
+          </p:cNvSpPr>
+          <p:nvPr>
+            <p:ph type="sldNum" idx="5" sz="quarter"/>
+          </p:nvPr>
+        </p:nvSpPr>
+        <p:spPr/>
+      </p:sp>
+    </p:spTree>
+  </p:cSld>
+  <p:clrMapOvr>
+    <a:masterClrMapping/>
+  </p:clrMapOvr>
+</p:notes>
+</file>
+
+<file path=ppt/notesSlides/notesSlide5.xml><?xml version="1.0" encoding="utf-8"?>
+<p:notes xmlns:a="http://schemas.openxmlformats.org/drawingml/2006/main" xmlns:p="http://schemas.openxmlformats.org/presentationml/2006/main" xmlns:r="http://schemas.openxmlformats.org/officeDocument/2006/relationships">
+  <p:cSld>
+    <p:spTree>
+      <p:nvGrpSpPr>
+        <p:cNvPr id="1" name=""/>
+        <p:cNvGrpSpPr/>
+        <p:nvPr/>
+      </p:nvGrpSpPr>
+      <p:grpSpPr>
+        <a:xfrm>
+          <a:off x="0" y="0"/>
+          <a:ext cx="0" cy="0"/>
+          <a:chOff x="0" y="0"/>
+          <a:chExt cx="0" cy="0"/>
+        </a:xfrm>
+      </p:grpSpPr>
+      <p:sp>
+        <p:nvSpPr>
+          <p:cNvPr id="2" name="Slide Image Placeholder 1"/>
+          <p:cNvSpPr>
+            <a:spLocks noGrp="1"/>
+          </p:cNvSpPr>
+          <p:nvPr>
+            <p:ph type="sldImg" idx="2"/>
+          </p:nvPr>
+        </p:nvSpPr>
+        <p:spPr/>
+      </p:sp>
+      <p:sp>
+        <p:nvSpPr>
+          <p:cNvPr id="3" name="Notes Placeholder 2"/>
+          <p:cNvSpPr>
+            <a:spLocks noGrp="1"/>
+          </p:cNvSpPr>
+          <p:nvPr>
+            <p:ph type="body" idx="3" sz="quarter"/>
+          </p:nvPr>
+        </p:nvSpPr>
+        <p:spPr/>
+        <p:txBody>
+          <a:bodyPr/>
+          <a:lstStyle/>
+          <a:p>
+            <a:r>
+              <a:t>Three steps: list the agents, write the literal fields each one needs, the union is the trait store and the per-agent subset is its contract. Demand-driven, not speculative.</a:t>
+            </a:r>
+          </a:p>
+        </p:txBody>
+      </p:sp>
+      <p:sp>
+        <p:nvSpPr>
+          <p:cNvPr id="4" name="Slide Number Placeholder 3"/>
+          <p:cNvSpPr>
+            <a:spLocks noGrp="1"/>
+          </p:cNvSpPr>
+          <p:nvPr>
+            <p:ph type="sldNum" idx="5" sz="quarter"/>
+          </p:nvPr>
+        </p:nvSpPr>
+        <p:spPr/>
+      </p:sp>
+    </p:spTree>
+  </p:cSld>
+  <p:clrMapOvr>
+    <a:masterClrMapping/>
+  </p:clrMapOvr>
+</p:notes>
+</file>
+
+<file path=ppt/notesSlides/notesSlide6.xml><?xml version="1.0" encoding="utf-8"?>
+<p:notes xmlns:a="http://schemas.openxmlformats.org/drawingml/2006/main" xmlns:p="http://schemas.openxmlformats.org/presentationml/2006/main" xmlns:r="http://schemas.openxmlformats.org/officeDocument/2006/relationships">
+  <p:cSld>
+    <p:spTree>
+      <p:nvGrpSpPr>
+        <p:cNvPr id="1" name=""/>
+        <p:cNvGrpSpPr/>
+        <p:nvPr/>
+      </p:nvGrpSpPr>
+      <p:grpSpPr>
+        <a:xfrm>
+          <a:off x="0" y="0"/>
+          <a:ext cx="0" cy="0"/>
+          <a:chOff x="0" y="0"/>
+          <a:chExt cx="0" cy="0"/>
+        </a:xfrm>
+      </p:grpSpPr>
+      <p:sp>
+        <p:nvSpPr>
+          <p:cNvPr id="2" name="Slide Image Placeholder 1"/>
+          <p:cNvSpPr>
+            <a:spLocks noGrp="1"/>
+          </p:cNvSpPr>
+          <p:nvPr>
+            <p:ph type="sldImg" idx="2"/>
+          </p:nvPr>
+        </p:nvSpPr>
+        <p:spPr/>
+      </p:sp>
+      <p:sp>
+        <p:nvSpPr>
+          <p:cNvPr id="3" name="Notes Placeholder 2"/>
+          <p:cNvSpPr>
+            <a:spLocks noGrp="1"/>
+          </p:cNvSpPr>
+          <p:nvPr>
+            <p:ph type="body" idx="3" sz="quarter"/>
+          </p:nvPr>
+        </p:nvSpPr>
+        <p:spPr/>
+        <p:txBody>
+          <a:bodyPr/>
+          <a:lstStyle/>
+          <a:p>
+            <a:r>
+              <a:t>One picture, left to right. Sources are the mess. One — AI maps any schema to canonical events. Two — identity resolution, the keystone. Three — event store is truth, trait store is derived. Four — the Context API; that's what the prototype IS. Then the agents, each a contract. Bottom — the closed loop, where outcomes sharpen the next decision.</a:t>
+            </a:r>
+          </a:p>
+        </p:txBody>
+      </p:sp>
+      <p:sp>
+        <p:nvSpPr>
+          <p:cNvPr id="4" name="Slide Number Placeholder 3"/>
+          <p:cNvSpPr>
+            <a:spLocks noGrp="1"/>
+          </p:cNvSpPr>
+          <p:nvPr>
+            <p:ph type="sldNum" idx="5" sz="quarter"/>
+          </p:nvPr>
+        </p:nvSpPr>
+        <p:spPr/>
+      </p:sp>
+    </p:spTree>
+  </p:cSld>
+  <p:clrMapOvr>
+    <a:masterClrMapping/>
+  </p:clrMapOvr>
+</p:notes>
+</file>
+
+<file path=ppt/notesSlides/notesSlide7.xml><?xml version="1.0" encoding="utf-8"?>
+<p:notes xmlns:a="http://schemas.openxmlformats.org/drawingml/2006/main" xmlns:p="http://schemas.openxmlformats.org/presentationml/2006/main" xmlns:r="http://schemas.openxmlformats.org/officeDocument/2006/relationships">
+  <p:cSld>
+    <p:spTree>
+      <p:nvGrpSpPr>
+        <p:cNvPr id="1" name=""/>
+        <p:cNvGrpSpPr/>
+        <p:nvPr/>
+      </p:nvGrpSpPr>
+      <p:grpSpPr>
+        <a:xfrm>
+          <a:off x="0" y="0"/>
+          <a:ext cx="0" cy="0"/>
+          <a:chOff x="0" y="0"/>
+          <a:chExt cx="0" cy="0"/>
+        </a:xfrm>
+      </p:grpSpPr>
+      <p:sp>
+        <p:nvSpPr>
+          <p:cNvPr id="2" name="Slide Image Placeholder 1"/>
+          <p:cNvSpPr>
+            <a:spLocks noGrp="1"/>
+          </p:cNvSpPr>
+          <p:nvPr>
+            <p:ph type="sldImg" idx="2"/>
+          </p:nvPr>
+        </p:nvSpPr>
+        <p:spPr/>
+      </p:sp>
+      <p:sp>
+        <p:nvSpPr>
+          <p:cNvPr id="3" name="Notes Placeholder 2"/>
+          <p:cNvSpPr>
+            <a:spLocks noGrp="1"/>
+          </p:cNvSpPr>
+          <p:nvPr>
+            <p:ph type="body" idx="3" sz="quarter"/>
+          </p:nvPr>
+        </p:nvSpPr>
+        <p:spPr/>
+        <p:txBody>
+          <a:bodyPr/>
+          <a:lstStyle/>
+          <a:p>
+            <a:r>
+              <a:t>Don't rush this — it's the keystone. Three escalating signals, each with a confidence. We tune for precision over recall: a wrong merge is worse than a missed one. Cross-brand is the same graph one level up. Then: two stores on purpose — events are immutable truth, traits are recomputed; a wrong trait, replay and recompute, and contracts never break because agents read traits.</a:t>
+            </a:r>
+          </a:p>
+        </p:txBody>
+      </p:sp>
+      <p:sp>
+        <p:nvSpPr>
+          <p:cNvPr id="4" name="Slide Number Placeholder 3"/>
+          <p:cNvSpPr>
+            <a:spLocks noGrp="1"/>
+          </p:cNvSpPr>
+          <p:nvPr>
+            <p:ph type="sldNum" idx="5" sz="quarter"/>
+          </p:nvPr>
+        </p:nvSpPr>
+        <p:spPr/>
+      </p:sp>
+    </p:spTree>
+  </p:cSld>
+  <p:clrMapOvr>
+    <a:masterClrMapping/>
+  </p:clrMapOvr>
+</p:notes>
+</file>
+
+<file path=ppt/notesSlides/notesSlide8.xml><?xml version="1.0" encoding="utf-8"?>
+<p:notes xmlns:a="http://schemas.openxmlformats.org/drawingml/2006/main" xmlns:p="http://schemas.openxmlformats.org/presentationml/2006/main" xmlns:r="http://schemas.openxmlformats.org/officeDocument/2006/relationships">
+  <p:cSld>
+    <p:spTree>
+      <p:nvGrpSpPr>
+        <p:cNvPr id="1" name=""/>
+        <p:cNvGrpSpPr/>
+        <p:nvPr/>
+      </p:nvGrpSpPr>
+      <p:grpSpPr>
+        <a:xfrm>
+          <a:off x="0" y="0"/>
+          <a:ext cx="0" cy="0"/>
+          <a:chOff x="0" y="0"/>
+          <a:chExt cx="0" cy="0"/>
+        </a:xfrm>
+      </p:grpSpPr>
+      <p:sp>
+        <p:nvSpPr>
+          <p:cNvPr id="2" name="Slide Image Placeholder 1"/>
+          <p:cNvSpPr>
+            <a:spLocks noGrp="1"/>
+          </p:cNvSpPr>
+          <p:nvPr>
+            <p:ph type="sldImg" idx="2"/>
+          </p:nvPr>
+        </p:nvSpPr>
+        <p:spPr/>
+      </p:sp>
+      <p:sp>
+        <p:nvSpPr>
+          <p:cNvPr id="3" name="Notes Placeholder 2"/>
+          <p:cNvSpPr>
+            <a:spLocks noGrp="1"/>
+          </p:cNvSpPr>
+          <p:nvPr>
+            <p:ph type="body" idx="3" sz="quarter"/>
+          </p:nvPr>
+        </p:nvSpPr>
+        <p:spPr/>
+        <p:txBody>
+          <a:bodyPr/>
+          <a:lstStyle/>
+          <a:p>
+            <a:r>
+              <a:t>Events are immutable truth; traits are derived and recomputed from them. A wrong trait? Replay and recompute. Because agents read traits, we can change how a trait is computed without touching a single contract.</a:t>
+            </a:r>
+          </a:p>
+        </p:txBody>
+      </p:sp>
+      <p:sp>
+        <p:nvSpPr>
+          <p:cNvPr id="4" name="Slide Number Placeholder 3"/>
+          <p:cNvSpPr>
+            <a:spLocks noGrp="1"/>
+          </p:cNvSpPr>
+          <p:nvPr>
+            <p:ph type="sldNum" idx="5" sz="quarter"/>
+          </p:nvPr>
+        </p:nvSpPr>
+        <p:spPr/>
+      </p:sp>
+    </p:spTree>
+  </p:cSld>
+  <p:clrMapOvr>
+    <a:masterClrMapping/>
+  </p:clrMapOvr>
+</p:notes>
+</file>
+
+<file path=ppt/notesSlides/notesSlide9.xml><?xml version="1.0" encoding="utf-8"?>
+<p:notes xmlns:a="http://schemas.openxmlformats.org/drawingml/2006/main" xmlns:p="http://schemas.openxmlformats.org/presentationml/2006/main" xmlns:r="http://schemas.openxmlformats.org/officeDocument/2006/relationships">
+  <p:cSld>
+    <p:spTree>
+      <p:nvGrpSpPr>
+        <p:cNvPr id="1" name=""/>
+        <p:cNvGrpSpPr/>
+        <p:nvPr/>
+      </p:nvGrpSpPr>
+      <p:grpSpPr>
+        <a:xfrm>
+          <a:off x="0" y="0"/>
+          <a:ext cx="0" cy="0"/>
+          <a:chOff x="0" y="0"/>
+          <a:chExt cx="0" cy="0"/>
+        </a:xfrm>
+      </p:grpSpPr>
+      <p:sp>
+        <p:nvSpPr>
+          <p:cNvPr id="2" name="Slide Image Placeholder 1"/>
+          <p:cNvSpPr>
+            <a:spLocks noGrp="1"/>
+          </p:cNvSpPr>
+          <p:nvPr>
+            <p:ph type="sldImg" idx="2"/>
+          </p:nvPr>
+        </p:nvSpPr>
+        <p:spPr/>
+      </p:sp>
+      <p:sp>
+        <p:nvSpPr>
+          <p:cNvPr id="3" name="Notes Placeholder 2"/>
+          <p:cNvSpPr>
+            <a:spLocks noGrp="1"/>
+          </p:cNvSpPr>
+          <p:nvPr>
+            <p:ph type="body" idx="3" sz="quarter"/>
+          </p:nvPr>
+        </p:nvSpPr>
+        <p:spPr/>
+        <p:txBody>
+          <a:bodyPr/>
+          <a:lstStyle/>
+          <a:p>
+            <a:r>
+              <a:t>Criterion two. Five places where AI replaces rules or humans. The prototype shows the last two LIVE — type English, get a segment; minimal context, get a real message. The first three are the same pattern, earlier in the pipeline. If you have a key, run the live generate here.</a:t>
+            </a:r>
+          </a:p>
+        </p:txBody>
+      </p:sp>
+      <p:sp>
+        <p:nvSpPr>
+          <p:cNvPr id="4" name="Slide Number Placeholder 3"/>
+          <p:cNvSpPr>
+            <a:spLocks noGrp="1"/>
+          </p:cNvSpPr>
+          <p:nvPr>
+            <p:ph type="sldNum" idx="5" sz="quarter"/>
+          </p:nvPr>
+        </p:nvSpPr>
+        <p:spPr/>
+      </p:sp>
+    </p:spTree>
+  </p:cSld>
+  <p:clrMapOvr>
+    <a:masterClrMapping/>
+  </p:clrMapOvr>
+</p:notes>
 </file>
 
 <file path=ppt/slideLayouts/slideLayout1.xml><?xml version="1.0" encoding="utf-8"?>
@@ -3199,39 +4739,6 @@
                 </a:solidFill>
               </a:rPr>
               <a:t>How to unify e-commerce customer data so AI agents can rely on it, across many brands</a:t>
-            </a:r>
-          </a:p>
-        </p:txBody>
-      </p:sp>
-      <p:sp>
-        <p:nvSpPr>
-          <p:cNvPr id="4" name="TextBox 3"/>
-          <p:cNvSpPr txBox="1"/>
-          <p:nvPr/>
-        </p:nvSpPr>
-        <p:spPr>
-          <a:xfrm>
-            <a:off x="822960" y="6035040"/>
-            <a:ext cx="10515600" cy="548640"/>
-          </a:xfrm>
-          <a:prstGeom prst="rect">
-            <a:avLst/>
-          </a:prstGeom>
-          <a:noFill/>
-        </p:spPr>
-        <p:txBody>
-          <a:bodyPr wrap="none">
-            <a:spAutoFit/>
-          </a:bodyPr>
-          <a:lstStyle/>
-          <a:p>
-            <a:r>
-              <a:rPr sz="1100">
-                <a:solidFill>
-                  <a:srgbClr val="94A3B8"/>
-                </a:solidFill>
-              </a:rPr>
-              <a:t>Companion deck to the interactive prototype · prototype proves #1/#3/#4 and shows #2 · this deck carries #5 + architecture</a:t>
             </a:r>
           </a:p>
         </p:txBody>
@@ -7217,7 +8724,7 @@
           <p:nvPr/>
         </p:nvPicPr>
         <p:blipFill>
-          <a:blip r:embed="rId2"/>
+          <a:blip r:embed="rId3"/>
           <a:stretch>
             <a:fillRect/>
           </a:stretch>
@@ -7260,7 +8767,7 @@
                   <a:srgbClr val="94A3B8"/>
                 </a:solidFill>
               </a:rPr>
-              <a:t>Sources → ① AI schema map → ② identity resolution → ③ event + trait store → ④ Context API → agents (one contract each) → closed learning loop</a:t>
+              <a:t>Sources → ① AI schema map → ② identity resolution → ③ event + trait store → ④ Context API → agents → closed loop</a:t>
             </a:r>
           </a:p>
         </p:txBody>
@@ -8767,4 +10274,324 @@
   </a:objectDefaults>
   <a:extraClrSchemeLst/>
 </a:theme>
+</file>
+
+<file path=ppt/theme/theme2.xml><?xml version="1.0" encoding="utf-8"?>
+<a:theme xmlns:a="http://schemas.openxmlformats.org/drawingml/2006/main" name="Office Theme">
+  <a:themeElements>
+    <a:clrScheme name="Office">
+      <a:dk1>
+        <a:sysClr val="windowText" lastClr="000000"/>
+      </a:dk1>
+      <a:lt1>
+        <a:sysClr val="window" lastClr="FFFFFF"/>
+      </a:lt1>
+      <a:dk2>
+        <a:srgbClr val="1F497D"/>
+      </a:dk2>
+      <a:lt2>
+        <a:srgbClr val="EEECE1"/>
+      </a:lt2>
+      <a:accent1>
+        <a:srgbClr val="4F81BD"/>
+      </a:accent1>
+      <a:accent2>
+        <a:srgbClr val="C0504D"/>
+      </a:accent2>
+      <a:accent3>
+        <a:srgbClr val="9BBB59"/>
+      </a:accent3>
+      <a:accent4>
+        <a:srgbClr val="8064A2"/>
+      </a:accent4>
+      <a:accent5>
+        <a:srgbClr val="4BACC6"/>
+      </a:accent5>
+      <a:accent6>
+        <a:srgbClr val="F79646"/>
+      </a:accent6>
+      <a:hlink>
+        <a:srgbClr val="0000FF"/>
+      </a:hlink>
+      <a:folHlink>
+        <a:srgbClr val="800080"/>
+      </a:folHlink>
+    </a:clrScheme>
+    <a:fontScheme name="Office">
+      <a:majorFont>
+        <a:latin typeface="Calibri"/>
+        <a:ea typeface=""/>
+        <a:cs typeface=""/>
+        <a:font script="Jpan" typeface="ＭＳ Ｐゴシック"/>
+        <a:font script="Hang" typeface="맑은 고딕"/>
+        <a:font script="Hans" typeface="宋体"/>
+        <a:font script="Hant" typeface="新細明體"/>
+        <a:font script="Arab" typeface="Times New Roman"/>
+        <a:font script="Hebr" typeface="Times New Roman"/>
+        <a:font script="Thai" typeface="Angsana New"/>
+        <a:font script="Ethi" typeface="Nyala"/>
+        <a:font script="Beng" typeface="Vrinda"/>
+        <a:font script="Gujr" typeface="Shruti"/>
+        <a:font script="Khmr" typeface="MoolBoran"/>
+        <a:font script="Knda" typeface="Tunga"/>
+        <a:font script="Guru" typeface="Raavi"/>
+        <a:font script="Cans" typeface="Euphemia"/>
+        <a:font script="Cher" typeface="Plantagenet Cherokee"/>
+        <a:font script="Yiii" typeface="Microsoft Yi Baiti"/>
+        <a:font script="Tibt" typeface="Microsoft Himalaya"/>
+        <a:font script="Thaa" typeface="MV Boli"/>
+        <a:font script="Deva" typeface="Mangal"/>
+        <a:font script="Telu" typeface="Gautami"/>
+        <a:font script="Taml" typeface="Latha"/>
+        <a:font script="Syrc" typeface="Estrangelo Edessa"/>
+        <a:font script="Orya" typeface="Kalinga"/>
+        <a:font script="Mlym" typeface="Kartika"/>
+        <a:font script="Laoo" typeface="DokChampa"/>
+        <a:font script="Sinh" typeface="Iskoola Pota"/>
+        <a:font script="Mong" typeface="Mongolian Baiti"/>
+        <a:font script="Viet" typeface="Times New Roman"/>
+        <a:font script="Uigh" typeface="Microsoft Uighur"/>
+        <a:font script="Geor" typeface="Sylfaen"/>
+      </a:majorFont>
+      <a:minorFont>
+        <a:latin typeface="Calibri"/>
+        <a:ea typeface=""/>
+        <a:cs typeface=""/>
+        <a:font script="Jpan" typeface="ＭＳ Ｐゴシック"/>
+        <a:font script="Hang" typeface="맑은 고딕"/>
+        <a:font script="Hans" typeface="宋体"/>
+        <a:font script="Hant" typeface="新細明體"/>
+        <a:font script="Arab" typeface="Arial"/>
+        <a:font script="Hebr" typeface="Arial"/>
+        <a:font script="Thai" typeface="Cordia New"/>
+        <a:font script="Ethi" typeface="Nyala"/>
+        <a:font script="Beng" typeface="Vrinda"/>
+        <a:font script="Gujr" typeface="Shruti"/>
+        <a:font script="Khmr" typeface="DaunPenh"/>
+        <a:font script="Knda" typeface="Tunga"/>
+        <a:font script="Guru" typeface="Raavi"/>
+        <a:font script="Cans" typeface="Euphemia"/>
+        <a:font script="Cher" typeface="Plantagenet Cherokee"/>
+        <a:font script="Yiii" typeface="Microsoft Yi Baiti"/>
+        <a:font script="Tibt" typeface="Microsoft Himalaya"/>
+        <a:font script="Thaa" typeface="MV Boli"/>
+        <a:font script="Deva" typeface="Mangal"/>
+        <a:font script="Telu" typeface="Gautami"/>
+        <a:font script="Taml" typeface="Latha"/>
+        <a:font script="Syrc" typeface="Estrangelo Edessa"/>
+        <a:font script="Orya" typeface="Kalinga"/>
+        <a:font script="Mlym" typeface="Kartika"/>
+        <a:font script="Laoo" typeface="DokChampa"/>
+        <a:font script="Sinh" typeface="Iskoola Pota"/>
+        <a:font script="Mong" typeface="Mongolian Baiti"/>
+        <a:font script="Viet" typeface="Arial"/>
+        <a:font script="Uigh" typeface="Microsoft Uighur"/>
+        <a:font script="Geor" typeface="Sylfaen"/>
+      </a:minorFont>
+    </a:fontScheme>
+    <a:fmtScheme name="Office">
+      <a:fillStyleLst>
+        <a:solidFill>
+          <a:schemeClr val="phClr"/>
+        </a:solidFill>
+        <a:gradFill rotWithShape="1">
+          <a:gsLst>
+            <a:gs pos="0">
+              <a:schemeClr val="phClr">
+                <a:tint val="50000"/>
+                <a:satMod val="300000"/>
+              </a:schemeClr>
+            </a:gs>
+            <a:gs pos="35000">
+              <a:schemeClr val="phClr">
+                <a:tint val="37000"/>
+                <a:satMod val="300000"/>
+              </a:schemeClr>
+            </a:gs>
+            <a:gs pos="100000">
+              <a:schemeClr val="phClr">
+                <a:tint val="15000"/>
+                <a:satMod val="350000"/>
+              </a:schemeClr>
+            </a:gs>
+          </a:gsLst>
+          <a:lin ang="16200000" scaled="1"/>
+        </a:gradFill>
+        <a:gradFill rotWithShape="1">
+          <a:gsLst>
+            <a:gs pos="0">
+              <a:schemeClr val="phClr">
+                <a:tint val="100000"/>
+                <a:shade val="100000"/>
+                <a:satMod val="130000"/>
+              </a:schemeClr>
+            </a:gs>
+            <a:gs pos="100000">
+              <a:schemeClr val="phClr">
+                <a:tint val="50000"/>
+                <a:shade val="100000"/>
+                <a:satMod val="350000"/>
+              </a:schemeClr>
+            </a:gs>
+          </a:gsLst>
+          <a:lin ang="16200000" scaled="0"/>
+        </a:gradFill>
+      </a:fillStyleLst>
+      <a:lnStyleLst>
+        <a:ln w="9525" cap="flat" cmpd="sng" algn="ctr">
+          <a:solidFill>
+            <a:schemeClr val="phClr">
+              <a:shade val="95000"/>
+              <a:satMod val="105000"/>
+            </a:schemeClr>
+          </a:solidFill>
+          <a:prstDash val="solid"/>
+        </a:ln>
+        <a:ln w="25400" cap="flat" cmpd="sng" algn="ctr">
+          <a:solidFill>
+            <a:schemeClr val="phClr"/>
+          </a:solidFill>
+          <a:prstDash val="solid"/>
+        </a:ln>
+        <a:ln w="38100" cap="flat" cmpd="sng" algn="ctr">
+          <a:solidFill>
+            <a:schemeClr val="phClr"/>
+          </a:solidFill>
+          <a:prstDash val="solid"/>
+        </a:ln>
+      </a:lnStyleLst>
+      <a:effectStyleLst>
+        <a:effectStyle>
+          <a:effectLst>
+            <a:outerShdw blurRad="40000" dist="20000" dir="5400000" rotWithShape="0">
+              <a:srgbClr val="000000">
+                <a:alpha val="38000"/>
+              </a:srgbClr>
+            </a:outerShdw>
+          </a:effectLst>
+        </a:effectStyle>
+        <a:effectStyle>
+          <a:effectLst>
+            <a:outerShdw blurRad="40000" dist="23000" dir="5400000" rotWithShape="0">
+              <a:srgbClr val="000000">
+                <a:alpha val="35000"/>
+              </a:srgbClr>
+            </a:outerShdw>
+          </a:effectLst>
+        </a:effectStyle>
+        <a:effectStyle>
+          <a:effectLst>
+            <a:outerShdw blurRad="40000" dist="23000" dir="5400000" rotWithShape="0">
+              <a:srgbClr val="000000">
+                <a:alpha val="35000"/>
+              </a:srgbClr>
+            </a:outerShdw>
+          </a:effectLst>
+          <a:scene3d>
+            <a:camera prst="orthographicFront">
+              <a:rot lat="0" lon="0" rev="0"/>
+            </a:camera>
+            <a:lightRig rig="threePt" dir="t">
+              <a:rot lat="0" lon="0" rev="1200000"/>
+            </a:lightRig>
+          </a:scene3d>
+          <a:sp3d>
+            <a:bevelT w="63500" h="25400"/>
+          </a:sp3d>
+        </a:effectStyle>
+      </a:effectStyleLst>
+      <a:bgFillStyleLst>
+        <a:solidFill>
+          <a:schemeClr val="phClr"/>
+        </a:solidFill>
+        <a:gradFill rotWithShape="1">
+          <a:gsLst>
+            <a:gs pos="0">
+              <a:schemeClr val="phClr">
+                <a:tint val="40000"/>
+                <a:satMod val="350000"/>
+              </a:schemeClr>
+            </a:gs>
+            <a:gs pos="40000">
+              <a:schemeClr val="phClr">
+                <a:tint val="45000"/>
+                <a:shade val="99000"/>
+                <a:satMod val="350000"/>
+              </a:schemeClr>
+            </a:gs>
+            <a:gs pos="100000">
+              <a:schemeClr val="phClr">
+                <a:shade val="20000"/>
+                <a:satMod val="255000"/>
+              </a:schemeClr>
+            </a:gs>
+          </a:gsLst>
+          <a:path path="circle">
+            <a:fillToRect l="50000" t="-80000" r="50000" b="180000"/>
+          </a:path>
+        </a:gradFill>
+        <a:gradFill rotWithShape="1">
+          <a:gsLst>
+            <a:gs pos="0">
+              <a:schemeClr val="phClr">
+                <a:tint val="80000"/>
+                <a:satMod val="300000"/>
+              </a:schemeClr>
+            </a:gs>
+            <a:gs pos="100000">
+              <a:schemeClr val="phClr">
+                <a:shade val="30000"/>
+                <a:satMod val="200000"/>
+              </a:schemeClr>
+            </a:gs>
+          </a:gsLst>
+          <a:path path="circle">
+            <a:fillToRect l="50000" t="50000" r="50000" b="50000"/>
+          </a:path>
+        </a:gradFill>
+      </a:bgFillStyleLst>
+    </a:fmtScheme>
+  </a:themeElements>
+  <a:objectDefaults>
+    <a:spDef>
+      <a:spPr/>
+      <a:bodyPr/>
+      <a:lstStyle/>
+      <a:style>
+        <a:lnRef idx="1">
+          <a:schemeClr val="accent1"/>
+        </a:lnRef>
+        <a:fillRef idx="3">
+          <a:schemeClr val="accent1"/>
+        </a:fillRef>
+        <a:effectRef idx="2">
+          <a:schemeClr val="accent1"/>
+        </a:effectRef>
+        <a:fontRef idx="minor">
+          <a:schemeClr val="lt1"/>
+        </a:fontRef>
+      </a:style>
+    </a:spDef>
+    <a:lnDef>
+      <a:spPr/>
+      <a:bodyPr/>
+      <a:lstStyle/>
+      <a:style>
+        <a:lnRef idx="2">
+          <a:schemeClr val="accent1"/>
+        </a:lnRef>
+        <a:fillRef idx="0">
+          <a:schemeClr val="accent1"/>
+        </a:fillRef>
+        <a:effectRef idx="1">
+          <a:schemeClr val="accent1"/>
+        </a:effectRef>
+        <a:fontRef idx="minor">
+          <a:schemeClr val="tx1"/>
+        </a:fontRef>
+      </a:style>
+    </a:lnDef>
+  </a:objectDefaults>
+  <a:extraClrSchemeLst/>
+</a:theme>
 </file>
</xml_diff>